<commit_message>
docs: tighten final defense RUL terminology
</commit_message>
<xml_diff>
--- a/docx/final/工业轴承设备剩余寿命预测系统的实现-结题答辩.pptx
+++ b/docx/final/工业轴承设备剩余寿命预测系统的实现-结题答辩.pptx
@@ -6486,7 +6486,7 @@
                 </a:solidFill>
                 <a:latin typeface="PingFang SC"/>
               </a:rPr>
-              <a:t>为什么不是分类？</a:t>
+              <a:t>任务边界？</a:t>
             </a:r>
           </a:p>
         </p:txBody>
@@ -8288,7 +8288,7 @@
               </a:defRPr>
             </a:pPr>
             <a:r>
-              <a:t>项目不是做故障类型分类，而是面向预测性维护的轴承剩余寿命预测系统。</a:t>
+              <a:t>项目定位为面向预测性维护的轴承剩余寿命预测系统。</a:t>
             </a:r>
           </a:p>
           <a:p>
@@ -11301,7 +11301,7 @@
               </a:defRPr>
             </a:pPr>
             <a:r>
-              <a:t>峭度、脉冲因子对冲击性故障更敏感，适合捕捉早期异常波动。</a:t>
+              <a:t>峭度、脉冲因子对冲击性退化或失效更敏感，适合捕捉早期异常波动。</a:t>
             </a:r>
           </a:p>
           <a:p>

</xml_diff>

<commit_message>
docs: standardize course deliverables
</commit_message>
<xml_diff>
--- a/docx/final/工业轴承设备剩余寿命预测系统的实现-结题答辩.pptx
+++ b/docx/final/工业轴承设备剩余寿命预测系统的实现-结题答辩.pptx
@@ -3283,7 +3283,7 @@
                 </a:solidFill>
                 <a:latin typeface="PingFang SC"/>
               </a:rPr>
-              <a:t>小组成员：zyj、cyj、zdh、zy | 2026-06-14</a:t>
+              <a:t>小组成员：zyj、cyy、zdh、zy | 2026-06-14</a:t>
             </a:r>
           </a:p>
         </p:txBody>
@@ -4040,7 +4040,7 @@
               </a:defRPr>
             </a:pPr>
             <a:r>
-              <a:t>PHM/NASA 类 score 是挑战赛惩罚函数，不等同于 Huang 论文原版 Score。</a:t>
+              <a:t>PHM/RUL 非对称惩罚 score 是挑战赛惩罚函数，不等同于 Huang 论文原版 Score。</a:t>
             </a:r>
           </a:p>
           <a:p>

</xml_diff>

<commit_message>
docs: finalize formal reproduction evidence
</commit_message>
<xml_diff>
--- a/docx/final/工业轴承设备剩余寿命预测系统的实现-结题答辩.pptx
+++ b/docx/final/工业轴承设备剩余寿命预测系统的实现-结题答辩.pptx
@@ -3283,7 +3283,7 @@
                 </a:solidFill>
                 <a:latin typeface="PingFang SC"/>
               </a:rPr>
-              <a:t>小组成员：zyj、cyy、zdh、zy | 2026-06-14</a:t>
+              <a:t>小组成员：zyj、cyj、zdh、zy | 2026-06-14</a:t>
             </a:r>
           </a:p>
         </p:txBody>
@@ -4040,7 +4040,7 @@
               </a:defRPr>
             </a:pPr>
             <a:r>
-              <a:t>PHM/RUL 非对称惩罚 score 是挑战赛惩罚函数，不等同于 Huang 论文原版 Score。</a:t>
+              <a:t>PHM/NASA 类 score 是挑战赛惩罚函数，不等同于 Huang 论文原版 Score。</a:t>
             </a:r>
           </a:p>
           <a:p>
@@ -4072,7 +4072,7 @@
               </a:defRPr>
             </a:pPr>
             <a:r>
-              <a:t>小样本复现的主要价值是工程闭环和指标可落盘，不是追求论文表格完全相同。</a:t>
+              <a:t>96 快照抽样复现的主要价值是工程闭环、指标口径和 gap 表可复查，不把结果包装成作者全量训练。</a:t>
             </a:r>
           </a:p>
         </p:txBody>
@@ -4402,7 +4402,7 @@
                 </a:solidFill>
                 <a:latin typeface="PingFang SC"/>
               </a:rPr>
-              <a:t>31</a:t>
+              <a:t>39</a:t>
             </a:r>
           </a:p>
         </p:txBody>
@@ -4747,7 +4747,7 @@
                 </a:solidFill>
                 <a:latin typeface="PingFang SC"/>
               </a:rPr>
-              <a:t>8</a:t>
+              <a:t>50</a:t>
             </a:r>
           </a:p>
         </p:txBody>
@@ -4782,7 +4782,7 @@
                 </a:solidFill>
                 <a:latin typeface="PingFang SC"/>
               </a:rPr>
-              <a:t>真实训练 epoch</a:t>
+              <a:t>正式训练 epoch</a:t>
             </a:r>
           </a:p>
         </p:txBody>
@@ -6667,7 +6667,7 @@
                 </a:solidFill>
                 <a:latin typeface="PingFang SC"/>
               </a:rPr>
-              <a:t>小样本、8 epoch、CPU 友好验收</a:t>
+              <a:t>96 快照抽样、单次训练、本机算力约束</a:t>
             </a:r>
           </a:p>
         </p:txBody>
@@ -6701,7 +6701,7 @@
                 </a:solidFill>
                 <a:latin typeface="PingFang SC"/>
               </a:rPr>
-              <a:t>验证流程，不冒充完整论文数值</a:t>
+              <a:t>验证流程，不冒充作者全量训练</a:t>
             </a:r>
           </a:p>
         </p:txBody>
@@ -7255,7 +7255,7 @@
                 </a:solidFill>
                 <a:latin typeface="PingFang SC"/>
               </a:rPr>
-              <a:t>小样本 8 epoch，未做多随机种子统计</a:t>
+              <a:t>96 快照抽样，未做多随机种子统计</a:t>
             </a:r>
           </a:p>
         </p:txBody>
@@ -7539,7 +7539,7 @@
                 </a:solidFill>
                 <a:latin typeface="PingFang SC"/>
               </a:rPr>
-              <a:t>我们完成的是课程项目级真实训练复现和工程闭环，不把小样本结果包装成论文完整数值复现。</a:t>
+              <a:t>我们完成的是课程项目级真实训练复现和工程闭环，不把 96 快照抽样结果包装成作者全量训练。</a:t>
             </a:r>
           </a:p>
         </p:txBody>
@@ -8214,7 +8214,7 @@
                 </a:solidFill>
                 <a:latin typeface="PingFang SC"/>
               </a:rPr>
-              <a:t>31</a:t>
+              <a:t>39</a:t>
             </a:r>
           </a:p>
         </p:txBody>
@@ -8249,7 +8249,7 @@
                 </a:solidFill>
                 <a:latin typeface="PingFang SC"/>
               </a:rPr>
-              <a:t>自动化测试通过</a:t>
+              <a:t>全量测试通过</a:t>
             </a:r>
           </a:p>
         </p:txBody>
@@ -8423,7 +8423,7 @@
                 </a:solidFill>
                 <a:latin typeface="PingFang SC"/>
               </a:rPr>
-              <a:t>问题定义：为什么是 RUL</a:t>
+              <a:t>任务定义：预测剩余寿命</a:t>
             </a:r>
           </a:p>
         </p:txBody>
@@ -8882,7 +8882,7 @@
                 </a:solidFill>
                 <a:latin typeface="PingFang SC"/>
               </a:rPr>
-              <a:t>两个数据集都是 run-to-failure 退化过程，天然适合 RUL、健康指标和生存概率分析。</a:t>
+              <a:t>两个数据集都记录轴承从正常运行到失效前的采样过程，适合构造 RUL 标签和健康趋势。</a:t>
             </a:r>
           </a:p>
         </p:txBody>
@@ -13098,7 +13098,7 @@
                 </a:solidFill>
                 <a:latin typeface="PingFang SC"/>
               </a:rPr>
-              <a:t>系统不只是完成 CSV 读取，而是把不同数据集的采样周期、工况、通道和 RUL 单位统一到了后续训练接口。</a:t>
+              <a:t>系统处理的是按时间采集的退化轨迹，先统一采样周期、工况、通道和 RUL 单位，再进入训练接口。</a:t>
             </a:r>
           </a:p>
         </p:txBody>
@@ -13929,7 +13929,7 @@
                 </a:solidFill>
                 <a:latin typeface="PingFang SC"/>
               </a:rPr>
-              <a:t>Bearing1_5，8 epoch 小样本真实训练</a:t>
+              <a:t>condition_1，50 epoch，92 条预测</a:t>
             </a:r>
           </a:p>
         </p:txBody>
@@ -13963,7 +13963,7 @@
                 </a:solidFill>
                 <a:latin typeface="PingFang SC"/>
               </a:rPr>
-              <a:t>CNN-LSTM-AM RMSE 406.30</a:t>
+              <a:t>CNN-LSTM-AM NormalizedRMSE 0.1465</a:t>
             </a:r>
           </a:p>
         </p:txBody>
@@ -14076,7 +14076,7 @@
                 </a:solidFill>
                 <a:latin typeface="PingFang SC"/>
               </a:rPr>
-              <a:t>Bearing3_1，8 epoch 小样本真实训练</a:t>
+              <a:t>condition_1，50 epoch，92 条预测</a:t>
             </a:r>
           </a:p>
         </p:txBody>
@@ -14110,7 +14110,7 @@
                 </a:solidFill>
                 <a:latin typeface="PingFang SC"/>
               </a:rPr>
-              <a:t>CNN-LSTM-AM RMSE 651.04</a:t>
+              <a:t>CNN-LSTM-AM NormalizedRMSE 0.2222</a:t>
             </a:r>
           </a:p>
         </p:txBody>
@@ -14629,7 +14629,7 @@
                 </a:solidFill>
                 <a:latin typeface="PingFang SC"/>
               </a:rPr>
-              <a:t>为什么选它</a:t>
+              <a:t>选择依据</a:t>
             </a:r>
           </a:p>
         </p:txBody>
@@ -14819,7 +14819,7 @@
                 </a:solidFill>
                 <a:latin typeface="PingFang SC"/>
               </a:rPr>
-              <a:t>XLSTM-Transformer = 指数门控 memory 分支 + Transformer encoder + RUL head。</a:t>
+              <a:t>XLSTM-Transformer = 指数门控 memory 分支 + Transformer encoder + RUL head，并追加快照时间索引特征。</a:t>
             </a:r>
           </a:p>
         </p:txBody>
@@ -14989,7 +14989,7 @@
         <p:spPr>
           <a:xfrm>
             <a:off x="777240" y="3063240"/>
-            <a:ext cx="10789920" cy="530352"/>
+            <a:ext cx="10789920" cy="438912"/>
           </a:xfrm>
           <a:prstGeom prst="rect">
             <a:avLst/>
@@ -15135,8 +15135,8 @@
         </p:nvSpPr>
         <p:spPr>
           <a:xfrm>
-            <a:off x="777240" y="3630168"/>
-            <a:ext cx="10789920" cy="530352"/>
+            <a:off x="777240" y="3538728"/>
+            <a:ext cx="10789920" cy="438912"/>
           </a:xfrm>
           <a:prstGeom prst="rect">
             <a:avLst/>
@@ -15180,7 +15180,7 @@
         </p:nvSpPr>
         <p:spPr>
           <a:xfrm>
-            <a:off x="914400" y="3730752"/>
+            <a:off x="914400" y="3639312"/>
             <a:ext cx="2514600" cy="182880"/>
           </a:xfrm>
           <a:prstGeom prst="rect">
@@ -15214,7 +15214,7 @@
         </p:nvSpPr>
         <p:spPr>
           <a:xfrm>
-            <a:off x="3611880" y="3730752"/>
+            <a:off x="3611880" y="3639312"/>
             <a:ext cx="3749039" cy="182880"/>
           </a:xfrm>
           <a:prstGeom prst="rect">
@@ -15248,7 +15248,7 @@
         </p:nvSpPr>
         <p:spPr>
           <a:xfrm>
-            <a:off x="7589520" y="3730752"/>
+            <a:off x="7589520" y="3639312"/>
             <a:ext cx="3657600" cy="182880"/>
           </a:xfrm>
           <a:prstGeom prst="rect">
@@ -15282,8 +15282,8 @@
         </p:nvSpPr>
         <p:spPr>
           <a:xfrm>
-            <a:off x="777240" y="4197096"/>
-            <a:ext cx="10789920" cy="530352"/>
+            <a:off x="777240" y="4014216"/>
+            <a:ext cx="10789920" cy="438912"/>
           </a:xfrm>
           <a:prstGeom prst="rect">
             <a:avLst/>
@@ -15327,7 +15327,7 @@
         </p:nvSpPr>
         <p:spPr>
           <a:xfrm>
-            <a:off x="914400" y="4297680"/>
+            <a:off x="914400" y="4114800"/>
             <a:ext cx="2514600" cy="182880"/>
           </a:xfrm>
           <a:prstGeom prst="rect">
@@ -15348,6 +15348,153 @@
                 </a:solidFill>
                 <a:latin typeface="PingFang SC"/>
               </a:rPr>
+              <a:t>代表结果</a:t>
+            </a:r>
+          </a:p>
+        </p:txBody>
+      </p:sp>
+      <p:sp>
+        <p:nvSpPr>
+          <p:cNvPr id="30" name="TextBox 29"/>
+          <p:cNvSpPr txBox="1"/>
+          <p:nvPr/>
+        </p:nvSpPr>
+        <p:spPr>
+          <a:xfrm>
+            <a:off x="3611880" y="4114800"/>
+            <a:ext cx="3749039" cy="182880"/>
+          </a:xfrm>
+          <a:prstGeom prst="rect">
+            <a:avLst/>
+          </a:prstGeom>
+          <a:noFill/>
+        </p:spPr>
+        <p:txBody>
+          <a:bodyPr wrap="square">
+            <a:spAutoFit/>
+          </a:bodyPr>
+          <a:lstStyle/>
+          <a:p>
+            <a:r>
+              <a:rPr sz="1200" b="0">
+                <a:solidFill>
+                  <a:srgbClr val="111827"/>
+                </a:solidFill>
+                <a:latin typeface="PingFang SC"/>
+              </a:rPr>
+              <a:t>XJTU-SY condition 1 NRMSE 0.0646，R2 0.9506</a:t>
+            </a:r>
+          </a:p>
+        </p:txBody>
+      </p:sp>
+      <p:sp>
+        <p:nvSpPr>
+          <p:cNvPr id="31" name="TextBox 30"/>
+          <p:cNvSpPr txBox="1"/>
+          <p:nvPr/>
+        </p:nvSpPr>
+        <p:spPr>
+          <a:xfrm>
+            <a:off x="7589520" y="4114800"/>
+            <a:ext cx="3657600" cy="182880"/>
+          </a:xfrm>
+          <a:prstGeom prst="rect">
+            <a:avLst/>
+          </a:prstGeom>
+          <a:noFill/>
+        </p:spPr>
+        <p:txBody>
+          <a:bodyPr wrap="square">
+            <a:spAutoFit/>
+          </a:bodyPr>
+          <a:lstStyle/>
+          <a:p>
+            <a:r>
+              <a:rPr sz="1200" b="0">
+                <a:solidFill>
+                  <a:srgbClr val="475569"/>
+                </a:solidFill>
+                <a:latin typeface="PingFang SC"/>
+              </a:rPr>
+              <a:t>PHM2012 condition 3 NRMSE 0.1076，R2 0.8640</a:t>
+            </a:r>
+          </a:p>
+        </p:txBody>
+      </p:sp>
+      <p:sp>
+        <p:nvSpPr>
+          <p:cNvPr id="32" name="Rectangle 31"/>
+          <p:cNvSpPr/>
+          <p:nvPr/>
+        </p:nvSpPr>
+        <p:spPr>
+          <a:xfrm>
+            <a:off x="777240" y="4489704"/>
+            <a:ext cx="10789920" cy="438912"/>
+          </a:xfrm>
+          <a:prstGeom prst="rect">
+            <a:avLst/>
+          </a:prstGeom>
+          <a:solidFill>
+            <a:srgbClr val="FFFFFF"/>
+          </a:solidFill>
+          <a:ln>
+            <a:solidFill>
+              <a:srgbClr val="E2E8F0"/>
+            </a:solidFill>
+          </a:ln>
+        </p:spPr>
+        <p:style>
+          <a:lnRef idx="1">
+            <a:schemeClr val="accent1"/>
+          </a:lnRef>
+          <a:fillRef idx="3">
+            <a:schemeClr val="accent1"/>
+          </a:fillRef>
+          <a:effectRef idx="2">
+            <a:schemeClr val="accent1"/>
+          </a:effectRef>
+          <a:fontRef idx="minor">
+            <a:schemeClr val="lt1"/>
+          </a:fontRef>
+        </p:style>
+        <p:txBody>
+          <a:bodyPr rtlCol="0" anchor="ctr"/>
+          <a:lstStyle/>
+          <a:p>
+            <a:pPr algn="ctr"/>
+          </a:p>
+        </p:txBody>
+      </p:sp>
+      <p:sp>
+        <p:nvSpPr>
+          <p:cNvPr id="33" name="TextBox 32"/>
+          <p:cNvSpPr txBox="1"/>
+          <p:nvPr/>
+        </p:nvSpPr>
+        <p:spPr>
+          <a:xfrm>
+            <a:off x="914400" y="4590288"/>
+            <a:ext cx="2514600" cy="182880"/>
+          </a:xfrm>
+          <a:prstGeom prst="rect">
+            <a:avLst/>
+          </a:prstGeom>
+          <a:noFill/>
+        </p:spPr>
+        <p:txBody>
+          <a:bodyPr wrap="square">
+            <a:spAutoFit/>
+          </a:bodyPr>
+          <a:lstStyle/>
+          <a:p>
+            <a:r>
+              <a:rPr sz="1200" b="1">
+                <a:solidFill>
+                  <a:srgbClr val="111827"/>
+                </a:solidFill>
+                <a:latin typeface="PingFang SC"/>
+              </a:rPr>
               <a:t>边界</a:t>
             </a:r>
           </a:p>
@@ -15355,13 +15502,13 @@
       </p:sp>
       <p:sp>
         <p:nvSpPr>
-          <p:cNvPr id="30" name="TextBox 29"/>
-          <p:cNvSpPr txBox="1"/>
-          <p:nvPr/>
-        </p:nvSpPr>
-        <p:spPr>
-          <a:xfrm>
-            <a:off x="3611880" y="4297680"/>
+          <p:cNvPr id="34" name="TextBox 33"/>
+          <p:cNvSpPr txBox="1"/>
+          <p:nvPr/>
+        </p:nvSpPr>
+        <p:spPr>
+          <a:xfrm>
+            <a:off x="3611880" y="4590288"/>
             <a:ext cx="3749039" cy="182880"/>
           </a:xfrm>
           <a:prstGeom prst="rect">
@@ -15382,20 +15529,20 @@
                 </a:solidFill>
                 <a:latin typeface="PingFang SC"/>
               </a:rPr>
-              <a:t>论文结构 + 项目特征管线适配</a:t>
-            </a:r>
-          </a:p>
-        </p:txBody>
-      </p:sp>
-      <p:sp>
-        <p:nvSpPr>
-          <p:cNvPr id="31" name="TextBox 30"/>
-          <p:cNvSpPr txBox="1"/>
-          <p:nvPr/>
-        </p:nvSpPr>
-        <p:spPr>
-          <a:xfrm>
-            <a:off x="7589520" y="4297680"/>
+              <a:t>PHM2012 condition 2 NRMSE 0.3742，R2 -0.6439</a:t>
+            </a:r>
+          </a:p>
+        </p:txBody>
+      </p:sp>
+      <p:sp>
+        <p:nvSpPr>
+          <p:cNvPr id="35" name="TextBox 34"/>
+          <p:cNvSpPr txBox="1"/>
+          <p:nvPr/>
+        </p:nvSpPr>
+        <p:spPr>
+          <a:xfrm>
+            <a:off x="7589520" y="4590288"/>
             <a:ext cx="3657600" cy="182880"/>
           </a:xfrm>
           <a:prstGeom prst="rect">
@@ -15416,7 +15563,7 @@
                 </a:solidFill>
                 <a:latin typeface="PingFang SC"/>
               </a:rPr>
-              <a:t>非作者源码逐行复刻</a:t>
+              <a:t>Score 尺度仍有明显 gap</a:t>
             </a:r>
           </a:p>
         </p:txBody>

</xml_diff>

<commit_message>
Strengthen tsfresh issue 4 analysis
</commit_message>
<xml_diff>
--- a/docx/final/工业轴承设备剩余寿命预测系统的实现-结题答辩.pptx
+++ b/docx/final/工业轴承设备剩余寿命预测系统的实现-结题答辩.pptx
@@ -3613,7 +3613,7 @@
                 </a:solidFill>
                 <a:latin typeface="PingFang SC"/>
               </a:rPr>
-              <a:t>tsfresh</a:t>
+              <a:t>tsfresh Minimal</a:t>
             </a:r>
           </a:p>
         </p:txBody>
@@ -3647,7 +3647,7 @@
                 </a:solidFill>
                 <a:latin typeface="PingFang SC"/>
               </a:rPr>
-              <a:t>selected features + RandomForest mean NRMSE 0.315629</a:t>
+              <a:t>selected RF mean NRMSE 0.315629</a:t>
             </a:r>
           </a:p>
         </p:txBody>
@@ -3681,7 +3681,7 @@
                 </a:solidFill>
                 <a:latin typeface="PingFang SC"/>
               </a:rPr>
-              <a:t>相关性整体偏弱，不是核心性能突破</a:t>
+              <a:t>top correlation 0.200994，相关性整体偏弱</a:t>
             </a:r>
           </a:p>
         </p:txBody>
@@ -3760,7 +3760,7 @@
                 </a:solidFill>
                 <a:latin typeface="PingFang SC"/>
               </a:rPr>
-              <a:t>sktime RocketRegressor</a:t>
+              <a:t>tsfresh Efficient</a:t>
             </a:r>
           </a:p>
         </p:txBody>
@@ -3794,7 +3794,7 @@
                 </a:solidFill>
                 <a:latin typeface="PingFang SC"/>
               </a:rPr>
-              <a:t>held-out Bearing1_3 mean NRMSE 0.263706</a:t>
+              <a:t>selected RF mean NRMSE 0.318682；manual+selected 0.319927</a:t>
             </a:r>
           </a:p>
         </p:txBody>
@@ -3828,7 +3828,7 @@
                 </a:solidFill>
                 <a:latin typeface="PingFang SC"/>
               </a:rPr>
-              <a:t>当前优于 tsfresh RF，是补充 baseline</a:t>
+              <a:t>top correlation 0.424468，但不是核心突破</a:t>
             </a:r>
           </a:p>
         </p:txBody>
@@ -3907,7 +3907,7 @@
                 </a:solidFill>
                 <a:latin typeface="PingFang SC"/>
               </a:rPr>
-              <a:t>RULSurv row-level</a:t>
+              <a:t>sktime RocketRegressor</a:t>
             </a:r>
           </a:p>
         </p:txBody>
@@ -3941,7 +3941,7 @@
                 </a:solidFill>
                 <a:latin typeface="PingFang SC"/>
               </a:rPr>
-              <a:t>25% censored CV mean true MAE 6.926416 min</a:t>
+              <a:t>held-out Bearing1_3 mean NRMSE 0.263706</a:t>
             </a:r>
           </a:p>
         </p:txBody>
@@ -3975,7 +3975,7 @@
                 </a:solidFill>
                 <a:latin typeface="PingFang SC"/>
               </a:rPr>
-              <a:t>PROTOCOL_PASS，但不是 held-out 泛化</a:t>
+              <a:t>当前优于 tsfresh RF，是补充 baseline</a:t>
             </a:r>
           </a:p>
         </p:txBody>
@@ -4054,7 +4054,7 @@
                 </a:solidFill>
                 <a:latin typeface="PingFang SC"/>
               </a:rPr>
-              <a:t>RULSurv held-out</a:t>
+              <a:t>RULSurv row-level</a:t>
             </a:r>
           </a:p>
         </p:txBody>
@@ -4088,7 +4088,7 @@
                 </a:solidFill>
                 <a:latin typeface="PingFang SC"/>
               </a:rPr>
-              <a:t>Bearing1_3 mean true MAE 14.307856 min</a:t>
+              <a:t>25% censored CV mean true MAE 6.926416 min</a:t>
             </a:r>
           </a:p>
         </p:txBody>
@@ -4122,7 +4122,7 @@
                 </a:solidFill>
                 <a:latin typeface="PingFang SC"/>
               </a:rPr>
-              <a:t>MIGRATION_PASS，survival_probability=0.25 保守解码</a:t>
+              <a:t>PROTOCOL_PASS，但不是 held-out 泛化</a:t>
             </a:r>
           </a:p>
         </p:txBody>
@@ -4201,7 +4201,7 @@
                 </a:solidFill>
                 <a:latin typeface="PingFang SC"/>
               </a:rPr>
-              <a:t>外部 SOTA</a:t>
+              <a:t>RULSurv held-out</a:t>
             </a:r>
           </a:p>
         </p:txBody>
@@ -4235,7 +4235,7 @@
                 </a:solidFill>
                 <a:latin typeface="PingFang SC"/>
               </a:rPr>
-              <a:t>AutoRUL / GNN / Weibull 完成 source pin 与依赖 probe</a:t>
+              <a:t>Bearing1_3 mean true MAE 14.307856 min</a:t>
             </a:r>
           </a:p>
         </p:txBody>
@@ -4269,23 +4269,23 @@
                 </a:solidFill>
                 <a:latin typeface="PingFang SC"/>
               </a:rPr>
-              <a:t>尚未在本地跑出指标，不能说已复现</a:t>
-            </a:r>
-          </a:p>
-        </p:txBody>
-      </p:sp>
-      <p:sp>
-        <p:nvSpPr>
-          <p:cNvPr id="28" name="Rounded Rectangle 27"/>
+              <a:t>MIGRATION_PASS，survival_probability=0.25 保守解码</a:t>
+            </a:r>
+          </a:p>
+        </p:txBody>
+      </p:sp>
+      <p:sp>
+        <p:nvSpPr>
+          <p:cNvPr id="28" name="Rectangle 27"/>
           <p:cNvSpPr/>
           <p:nvPr/>
         </p:nvSpPr>
         <p:spPr>
           <a:xfrm>
-            <a:off x="822960" y="4983480"/>
-            <a:ext cx="10515600" cy="658368"/>
-          </a:xfrm>
-          <a:prstGeom prst="roundRect">
+            <a:off x="685800" y="3904487"/>
+            <a:ext cx="10789920" cy="557784"/>
+          </a:xfrm>
+          <a:prstGeom prst="rect">
             <a:avLst/>
           </a:prstGeom>
           <a:solidFill>
@@ -4321,7 +4321,154 @@
       </p:sp>
       <p:sp>
         <p:nvSpPr>
-          <p:cNvPr id="29" name="Rectangle 28"/>
+          <p:cNvPr id="29" name="TextBox 28"/>
+          <p:cNvSpPr txBox="1"/>
+          <p:nvPr/>
+        </p:nvSpPr>
+        <p:spPr>
+          <a:xfrm>
+            <a:off x="822960" y="4005072"/>
+            <a:ext cx="2514600" cy="182880"/>
+          </a:xfrm>
+          <a:prstGeom prst="rect">
+            <a:avLst/>
+          </a:prstGeom>
+          <a:noFill/>
+        </p:spPr>
+        <p:txBody>
+          <a:bodyPr wrap="square">
+            <a:spAutoFit/>
+          </a:bodyPr>
+          <a:lstStyle/>
+          <a:p>
+            <a:r>
+              <a:rPr sz="1200" b="1">
+                <a:solidFill>
+                  <a:srgbClr val="111827"/>
+                </a:solidFill>
+                <a:latin typeface="PingFang SC"/>
+              </a:rPr>
+              <a:t>外部 SOTA</a:t>
+            </a:r>
+          </a:p>
+        </p:txBody>
+      </p:sp>
+      <p:sp>
+        <p:nvSpPr>
+          <p:cNvPr id="30" name="TextBox 29"/>
+          <p:cNvSpPr txBox="1"/>
+          <p:nvPr/>
+        </p:nvSpPr>
+        <p:spPr>
+          <a:xfrm>
+            <a:off x="3520440" y="4005072"/>
+            <a:ext cx="3749039" cy="182880"/>
+          </a:xfrm>
+          <a:prstGeom prst="rect">
+            <a:avLst/>
+          </a:prstGeom>
+          <a:noFill/>
+        </p:spPr>
+        <p:txBody>
+          <a:bodyPr wrap="square">
+            <a:spAutoFit/>
+          </a:bodyPr>
+          <a:lstStyle/>
+          <a:p>
+            <a:r>
+              <a:rPr sz="1200" b="0">
+                <a:solidFill>
+                  <a:srgbClr val="111827"/>
+                </a:solidFill>
+                <a:latin typeface="PingFang SC"/>
+              </a:rPr>
+              <a:t>AutoRUL / GNN / Weibull 完成 source pin 与依赖 probe</a:t>
+            </a:r>
+          </a:p>
+        </p:txBody>
+      </p:sp>
+      <p:sp>
+        <p:nvSpPr>
+          <p:cNvPr id="31" name="TextBox 30"/>
+          <p:cNvSpPr txBox="1"/>
+          <p:nvPr/>
+        </p:nvSpPr>
+        <p:spPr>
+          <a:xfrm>
+            <a:off x="7498079" y="4005072"/>
+            <a:ext cx="3657600" cy="182880"/>
+          </a:xfrm>
+          <a:prstGeom prst="rect">
+            <a:avLst/>
+          </a:prstGeom>
+          <a:noFill/>
+        </p:spPr>
+        <p:txBody>
+          <a:bodyPr wrap="square">
+            <a:spAutoFit/>
+          </a:bodyPr>
+          <a:lstStyle/>
+          <a:p>
+            <a:r>
+              <a:rPr sz="1200" b="0">
+                <a:solidFill>
+                  <a:srgbClr val="475569"/>
+                </a:solidFill>
+                <a:latin typeface="PingFang SC"/>
+              </a:rPr>
+              <a:t>尚未在本地跑出指标，不能说已复现</a:t>
+            </a:r>
+          </a:p>
+        </p:txBody>
+      </p:sp>
+      <p:sp>
+        <p:nvSpPr>
+          <p:cNvPr id="32" name="Rounded Rectangle 31"/>
+          <p:cNvSpPr/>
+          <p:nvPr/>
+        </p:nvSpPr>
+        <p:spPr>
+          <a:xfrm>
+            <a:off x="822960" y="4983480"/>
+            <a:ext cx="10515600" cy="658368"/>
+          </a:xfrm>
+          <a:prstGeom prst="roundRect">
+            <a:avLst/>
+          </a:prstGeom>
+          <a:solidFill>
+            <a:srgbClr val="FFFFFF"/>
+          </a:solidFill>
+          <a:ln>
+            <a:solidFill>
+              <a:srgbClr val="E2E8F0"/>
+            </a:solidFill>
+          </a:ln>
+        </p:spPr>
+        <p:style>
+          <a:lnRef idx="1">
+            <a:schemeClr val="accent1"/>
+          </a:lnRef>
+          <a:fillRef idx="3">
+            <a:schemeClr val="accent1"/>
+          </a:fillRef>
+          <a:effectRef idx="2">
+            <a:schemeClr val="accent1"/>
+          </a:effectRef>
+          <a:fontRef idx="minor">
+            <a:schemeClr val="lt1"/>
+          </a:fontRef>
+        </p:style>
+        <p:txBody>
+          <a:bodyPr rtlCol="0" anchor="ctr"/>
+          <a:lstStyle/>
+          <a:p>
+            <a:pPr algn="ctr"/>
+          </a:p>
+        </p:txBody>
+      </p:sp>
+      <p:sp>
+        <p:nvSpPr>
+          <p:cNvPr id="33" name="Rectangle 32"/>
           <p:cNvSpPr/>
           <p:nvPr/>
         </p:nvSpPr>
@@ -4364,7 +4511,7 @@
       </p:sp>
       <p:sp>
         <p:nvSpPr>
-          <p:cNvPr id="30" name="TextBox 29"/>
+          <p:cNvPr id="34" name="TextBox 33"/>
           <p:cNvSpPr txBox="1"/>
           <p:nvPr/>
         </p:nvSpPr>
@@ -4398,7 +4545,7 @@
       </p:sp>
       <p:sp>
         <p:nvSpPr>
-          <p:cNvPr id="31" name="TextBox 30"/>
+          <p:cNvPr id="35" name="TextBox 34"/>
           <p:cNvSpPr txBox="1"/>
           <p:nvPr/>
         </p:nvSpPr>
@@ -7972,7 +8119,7 @@
                 </a:solidFill>
                 <a:latin typeface="PingFang SC"/>
               </a:rPr>
-              <a:t>已做 train-only baseline，但相关性整体偏弱</a:t>
+              <a:t>Minimal/Efficient 与 manual+tsfresh 已跑</a:t>
             </a:r>
           </a:p>
         </p:txBody>
@@ -8006,7 +8153,7 @@
                 </a:solidFill>
                 <a:latin typeface="PingFang SC"/>
               </a:rPr>
-              <a:t>旁证，不是核心突破</a:t>
+              <a:t>RF 仍弱于 Rocket，不是核心突破</a:t>
             </a:r>
           </a:p>
         </p:txBody>
@@ -8844,7 +8991,7 @@
                 </a:solidFill>
                 <a:latin typeface="PingFang SC"/>
               </a:rPr>
-              <a:t>外部 SOTA 未重跑；tsfresh 相关性整体偏弱；RULSurv held-out 是 survival_probability=0.25 的保守解码迁移结果。</a:t>
+              <a:t>外部 SOTA 未重跑；tsfresh 已做 Minimal/Efficient 与 manual+tsfresh，但不是核心突破；RULSurv held-out 是 survival_probability=0.25 的保守解码迁移结果。</a:t>
             </a:r>
           </a:p>
         </p:txBody>
@@ -12638,7 +12785,7 @@
               </a:defRPr>
             </a:pPr>
             <a:r>
-              <a:t>tsfresh 已完成 train-only 筛选，但相关性整体偏弱：top correlation 约 0.200994，只作为自动特征分析旁证。</a:t>
+              <a:t>tsfresh 已完成 Minimal/Efficient train-only 筛选、held-out baseline 和 manual+tsfresh 融合验证；RF NRMSE 仍弱于 Rocket，定位为自动特征分析旁证。</a:t>
             </a:r>
           </a:p>
         </p:txBody>

</xml_diff>